<commit_message>
feat: add speaker notes for ARCAD3X demo presentation
</commit_message>
<xml_diff>
--- a/ARCAD3X_DemoDay.pptx
+++ b/ARCAD3X_DemoDay.pptx
@@ -512,8 +512,36 @@
           <a:lstStyle/>
           <a:p>
             <a:r>
+              <a:rPr lang="en-US" b="1" dirty="0"/>
+              <a:t>SPEAKER NOTES  |  0:00 – 0:20  (20s)</a:t>
+            </a:r>
+            <a:endParaRPr lang="en-US" dirty="0"/>
+          </a:p>
+          <a:p>
+            <a:r>
               <a:rPr lang="en-US" dirty="0"/>
-              <a:t/>
+              <a:t>Hello everyone. My name is Hugo Ramos.</a:t>
+            </a:r>
+            <a:endParaRPr lang="en-US" dirty="0"/>
+          </a:p>
+          <a:p>
+            <a:r>
+              <a:rPr lang="en-US" dirty="0"/>
+              <a:t>This project is ARCAD3X. It is an arcade game with data tracking.</a:t>
+            </a:r>
+            <a:endParaRPr lang="en-US" dirty="0"/>
+          </a:p>
+          <a:p>
+            <a:r>
+              <a:rPr lang="en-US" dirty="0"/>
+              <a:t>The game is called Space Invaders 3: Last Night. I built it with Melissa Sbibih.</a:t>
+            </a:r>
+            <a:endParaRPr lang="en-US" dirty="0"/>
+          </a:p>
+          <a:p>
+            <a:r>
+              <a:rPr lang="en-US" dirty="0"/>
+              <a:t>In eight minutes, I will show you our full-stack project.</a:t>
             </a:r>
             <a:endParaRPr lang="en-US" dirty="0"/>
           </a:p>
@@ -600,8 +628,29 @@
           <a:lstStyle/>
           <a:p>
             <a:r>
+              <a:rPr lang="en-US" b="1" dirty="0"/>
+              <a:t>SPEAKER NOTES  |  6:45 – 7:15  (30s)</a:t>
+            </a:r>
+            <a:endParaRPr lang="en-US" dirty="0"/>
+          </a:p>
+          <a:p>
+            <a:r>
               <a:rPr lang="en-US" dirty="0"/>
-              <a:t/>
+              <a:t>What is next after the MVP? Our V3 plan:</a:t>
+            </a:r>
+            <a:endParaRPr lang="en-US" dirty="0"/>
+          </a:p>
+          <a:p>
+            <a:r>
+              <a:rPr lang="en-US" dirty="0"/>
+              <a:t>a story mode with cinematics. New worlds like Lava and Ice. Local multiplayer on one screen.</a:t>
+            </a:r>
+            <a:endParaRPr lang="en-US" dirty="0"/>
+          </a:p>
+          <a:p>
+            <a:r>
+              <a:rPr lang="en-US" dirty="0"/>
+              <a:t>Power-ups. Bosses at the end of each world. Daily quests. And a live leaderboard with WebSockets.</a:t>
             </a:r>
             <a:endParaRPr lang="en-US" dirty="0"/>
           </a:p>
@@ -688,8 +737,43 @@
           <a:lstStyle/>
           <a:p>
             <a:r>
+              <a:rPr lang="en-US" b="1" dirty="0"/>
+              <a:t>SPEAKER NOTES  |  7:15 – 7:45  (30s)</a:t>
+            </a:r>
+            <a:endParaRPr lang="en-US" dirty="0"/>
+          </a:p>
+          <a:p>
+            <a:r>
               <a:rPr lang="en-US" dirty="0"/>
-              <a:t/>
+              <a:t>Now, a quick demo. This is the main menu. You can play as guest or log in.</a:t>
+            </a:r>
+            <a:endParaRPr lang="en-US" dirty="0"/>
+          </a:p>
+          <a:p>
+            <a:r>
+              <a:rPr lang="en-US" dirty="0"/>
+              <a:t>Here you choose your character. Eight characters. Then you choose a level, by world.</a:t>
+            </a:r>
+            <a:endParaRPr lang="en-US" dirty="0"/>
+          </a:p>
+          <a:p>
+            <a:r>
+              <a:rPr lang="en-US" dirty="0"/>
+              <a:t>In the game you see the score, the lives, and the shield. Game over shows the top 20 leaderboard.</a:t>
+            </a:r>
+            <a:endParaRPr lang="en-US" dirty="0"/>
+          </a:p>
+          <a:p>
+            <a:r>
+              <a:rPr lang="en-US" dirty="0"/>
+              <a:t>The dashboard updates in real time. And the API docs are automatic, on /api/docs.</a:t>
+            </a:r>
+            <a:endParaRPr lang="en-US" dirty="0"/>
+          </a:p>
+          <a:p>
+            <a:r>
+              <a:rPr lang="en-US" dirty="0"/>
+              <a:t>One command: docker compose up. Then open localhost.</a:t>
             </a:r>
             <a:endParaRPr lang="en-US" dirty="0"/>
           </a:p>
@@ -776,8 +860,22 @@
           <a:lstStyle/>
           <a:p>
             <a:r>
+              <a:rPr lang="en-US" b="1" dirty="0"/>
+              <a:t>SPEAKER NOTES  |  7:45 – 8:00  (15s)</a:t>
+            </a:r>
+            <a:endParaRPr lang="en-US" dirty="0"/>
+          </a:p>
+          <a:p>
+            <a:r>
               <a:rPr lang="en-US" dirty="0"/>
-              <a:t/>
+              <a:t>So, this is ARCAD3X. Full-stack, 19 test suites, 4 Docker services, JWT security, and WASM ready.</a:t>
+            </a:r>
+            <a:endParaRPr lang="en-US" dirty="0"/>
+          </a:p>
+          <a:p>
+            <a:r>
+              <a:rPr lang="en-US" dirty="0"/>
+              <a:t>The code is on GitHub. Thank you very much. I am happy to answer your questions.</a:t>
             </a:r>
             <a:endParaRPr lang="en-US" dirty="0"/>
           </a:p>
@@ -864,8 +962,43 @@
           <a:lstStyle/>
           <a:p>
             <a:r>
+              <a:rPr lang="en-US" b="1" dirty="0"/>
+              <a:t>SPEAKER NOTES  |  0:20 – 1:00  (40s)</a:t>
+            </a:r>
+            <a:endParaRPr lang="en-US" dirty="0"/>
+          </a:p>
+          <a:p>
+            <a:r>
               <a:rPr lang="en-US" dirty="0"/>
-              <a:t/>
+              <a:t>First, the team. We are two full-stack game developers.</a:t>
+            </a:r>
+            <a:endParaRPr lang="en-US" dirty="0"/>
+          </a:p>
+          <a:p>
+            <a:r>
+              <a:rPr lang="en-US" dirty="0"/>
+              <a:t>I worked on the gameplay, the visuals, and the speed of the game. I also did the Docker part and the deployment.</a:t>
+            </a:r>
+            <a:endParaRPr lang="en-US" dirty="0"/>
+          </a:p>
+          <a:p>
+            <a:r>
+              <a:rPr lang="en-US" dirty="0"/>
+              <a:t>Melissa worked on the architecture and the data. She also did the documentation and the tests.</a:t>
+            </a:r>
+            <a:endParaRPr lang="en-US" dirty="0"/>
+          </a:p>
+          <a:p>
+            <a:r>
+              <a:rPr lang="en-US" dirty="0"/>
+              <a:t>The project has three parts: a 2D arcade game, a secure REST API with login, and a web dashboard for stats.</a:t>
+            </a:r>
+            <a:endParaRPr lang="en-US" dirty="0"/>
+          </a:p>
+          <a:p>
+            <a:r>
+              <a:rPr lang="en-US" dirty="0"/>
+              <a:t>Docker Compose runs everything together.</a:t>
             </a:r>
             <a:endParaRPr lang="en-US" dirty="0"/>
           </a:p>
@@ -952,8 +1085,43 @@
           <a:lstStyle/>
           <a:p>
             <a:r>
+              <a:rPr lang="en-US" b="1" dirty="0"/>
+              <a:t>SPEAKER NOTES  |  1:00 – 1:45  (45s)</a:t>
+            </a:r>
+            <a:endParaRPr lang="en-US" dirty="0"/>
+          </a:p>
+          <a:p>
+            <a:r>
               <a:rPr lang="en-US" dirty="0"/>
-              <a:t/>
+              <a:t>Where did the idea come from? Classic arcade games are fun. But when you die, everything is lost.</a:t>
+            </a:r>
+            <a:endParaRPr lang="en-US" dirty="0"/>
+          </a:p>
+          <a:p>
+            <a:r>
+              <a:rPr lang="en-US" dirty="0"/>
+              <a:t>No score history. No progress. You cannot compare with other players.</a:t>
+            </a:r>
+            <a:endParaRPr lang="en-US" dirty="0"/>
+          </a:p>
+          <a:p>
+            <a:r>
+              <a:rPr lang="en-US" dirty="0"/>
+              <a:t>So we mixed two things: the fun of arcade games, and the power of data.</a:t>
+            </a:r>
+            <a:endParaRPr lang="en-US" dirty="0"/>
+          </a:p>
+          <a:p>
+            <a:r>
+              <a:rPr lang="en-US" dirty="0"/>
+              <a:t>Now you can save scores, compare players, and see your progress.</a:t>
+            </a:r>
+            <a:endParaRPr lang="en-US" dirty="0"/>
+          </a:p>
+          <a:p>
+            <a:r>
+              <a:rPr lang="en-US" dirty="0"/>
+              <a:t>We built it in three steps. V1 was only the game in Pygame. V2 added login and scores. V3 is the full stack: API, database, and dashboard.</a:t>
             </a:r>
             <a:endParaRPr lang="en-US" dirty="0"/>
           </a:p>
@@ -1040,8 +1208,64 @@
           <a:lstStyle/>
           <a:p>
             <a:r>
+              <a:rPr lang="en-US" b="1" dirty="0"/>
+              <a:t>SPEAKER NOTES  |  1:45 – 2:45  (60s)</a:t>
+            </a:r>
+            <a:endParaRPr lang="en-US" dirty="0"/>
+          </a:p>
+          <a:p>
+            <a:r>
               <a:rPr lang="en-US" dirty="0"/>
-              <a:t/>
+              <a:t>This is our technology. We use Python and Pygame for the game. It is fast and good for 2D.</a:t>
+            </a:r>
+            <a:endParaRPr lang="en-US" dirty="0"/>
+          </a:p>
+          <a:p>
+            <a:r>
+              <a:rPr lang="en-US" dirty="0"/>
+              <a:t>With Pygbag, the game runs in the browser. No install needed.</a:t>
+            </a:r>
+            <a:endParaRPr lang="en-US" dirty="0"/>
+          </a:p>
+          <a:p>
+            <a:r>
+              <a:rPr lang="en-US" dirty="0"/>
+              <a:t>For the backend, we use Django Ninja. It gives automatic API docs and data checking.</a:t>
+            </a:r>
+            <a:endParaRPr lang="en-US" dirty="0"/>
+          </a:p>
+          <a:p>
+            <a:r>
+              <a:rPr lang="en-US" dirty="0"/>
+              <a:t>We store data in PostgreSQL 15. It is strong and ready for production.</a:t>
+            </a:r>
+            <a:endParaRPr lang="en-US" dirty="0"/>
+          </a:p>
+          <a:p>
+            <a:r>
+              <a:rPr lang="en-US" dirty="0"/>
+              <a:t>Redis 7 handles the token blacklist and blocks too many requests.</a:t>
+            </a:r>
+            <a:endParaRPr lang="en-US" dirty="0"/>
+          </a:p>
+          <a:p>
+            <a:r>
+              <a:rPr lang="en-US" dirty="0"/>
+              <a:t>For login, we made our own JWT system. It uses SHA-256 with a pepper, and token rotation.</a:t>
+            </a:r>
+            <a:endParaRPr lang="en-US" dirty="0"/>
+          </a:p>
+          <a:p>
+            <a:r>
+              <a:rPr lang="en-US" dirty="0"/>
+              <a:t>The dashboard is simple JavaScript. No build step.</a:t>
+            </a:r>
+            <a:endParaRPr lang="en-US" dirty="0"/>
+          </a:p>
+          <a:p>
+            <a:r>
+              <a:rPr lang="en-US" dirty="0"/>
+              <a:t>And everything runs in four Docker services, with one command.</a:t>
             </a:r>
             <a:endParaRPr lang="en-US" dirty="0"/>
           </a:p>
@@ -1128,8 +1352,43 @@
           <a:lstStyle/>
           <a:p>
             <a:r>
+              <a:rPr lang="en-US" b="1" dirty="0"/>
+              <a:t>SPEAKER NOTES  |  2:45 – 3:45  (60s)</a:t>
+            </a:r>
+            <a:endParaRPr lang="en-US" dirty="0"/>
+          </a:p>
+          <a:p>
+            <a:r>
               <a:rPr lang="en-US" dirty="0"/>
-              <a:t/>
+              <a:t>Here is some code. Top left: the JWT token. We create a token with the user id and a 24-hour timer.</a:t>
+            </a:r>
+            <a:endParaRPr lang="en-US" dirty="0"/>
+          </a:p>
+          <a:p>
+            <a:r>
+              <a:rPr lang="en-US" dirty="0"/>
+              <a:t>Below: the security facade. Before we send data, we remove secret keys like password and token. This is extra safety.</a:t>
+            </a:r>
+            <a:endParaRPr lang="en-US" dirty="0"/>
+          </a:p>
+          <a:p>
+            <a:r>
+              <a:rPr lang="en-US" dirty="0"/>
+              <a:t>On the right: the player in the game. It has a sprite, a speed, five lives, a shield, and a special attack.</a:t>
+            </a:r>
+            <a:endParaRPr lang="en-US" dirty="0"/>
+          </a:p>
+          <a:p>
+            <a:r>
+              <a:rPr lang="en-US" dirty="0"/>
+              <a:t>And the API endpoint. A user with a token sends their score and level, and we save the game session.</a:t>
+            </a:r>
+            <a:endParaRPr lang="en-US" dirty="0"/>
+          </a:p>
+          <a:p>
+            <a:r>
+              <a:rPr lang="en-US" dirty="0"/>
+              <a:t>Simple, safe, and checked.</a:t>
             </a:r>
             <a:endParaRPr lang="en-US" dirty="0"/>
           </a:p>
@@ -1216,8 +1475,36 @@
           <a:lstStyle/>
           <a:p>
             <a:r>
+              <a:rPr lang="en-US" b="1" dirty="0"/>
+              <a:t>SPEAKER NOTES  |  3:45 – 4:15  (30s)</a:t>
+            </a:r>
+            <a:endParaRPr lang="en-US" dirty="0"/>
+          </a:p>
+          <a:p>
+            <a:r>
               <a:rPr lang="en-US" dirty="0"/>
-              <a:t/>
+              <a:t>This is how it works together. Nginx is the front door on port 80.</a:t>
+            </a:r>
+            <a:endParaRPr lang="en-US" dirty="0"/>
+          </a:p>
+          <a:p>
+            <a:r>
+              <a:rPr lang="en-US" dirty="0"/>
+              <a:t>It sends /api to Django, /wasm to the game, and /dashboard to the web app.</a:t>
+            </a:r>
+            <a:endParaRPr lang="en-US" dirty="0"/>
+          </a:p>
+          <a:p>
+            <a:r>
+              <a:rPr lang="en-US" dirty="0"/>
+              <a:t>The dashboard gets data from the API with a token. Django talks to PostgreSQL and Redis.</a:t>
+            </a:r>
+            <a:endParaRPr lang="en-US" dirty="0"/>
+          </a:p>
+          <a:p>
+            <a:r>
+              <a:rPr lang="en-US" dirty="0"/>
+              <a:t>Four containers. One command.</a:t>
             </a:r>
             <a:endParaRPr lang="en-US" dirty="0"/>
           </a:p>
@@ -1304,8 +1591,43 @@
           <a:lstStyle/>
           <a:p>
             <a:r>
+              <a:rPr lang="en-US" b="1" dirty="0"/>
+              <a:t>SPEAKER NOTES  |  4:15 – 5:05  (50s)</a:t>
+            </a:r>
+            <a:endParaRPr lang="en-US" dirty="0"/>
+          </a:p>
+          <a:p>
+            <a:r>
               <a:rPr lang="en-US" dirty="0"/>
-              <a:t/>
+              <a:t>We worked in six phases. Phase 1: a simple game with menu, lives, and collisions.</a:t>
+            </a:r>
+            <a:endParaRPr lang="en-US" dirty="0"/>
+          </a:p>
+          <a:p>
+            <a:r>
+              <a:rPr lang="en-US" dirty="0"/>
+              <a:t>Phase 2: login and guest mode. Phase 3: the Django API with PostgreSQL and JWT.</a:t>
+            </a:r>
+            <a:endParaRPr lang="en-US" dirty="0"/>
+          </a:p>
+          <a:p>
+            <a:r>
+              <a:rPr lang="en-US" dirty="0"/>
+              <a:t>Phase 4: the dashboard with leaderboard and profiles. Phase 5: Docker, WASM, and tests.</a:t>
+            </a:r>
+            <a:endParaRPr lang="en-US" dirty="0"/>
+          </a:p>
+          <a:p>
+            <a:r>
+              <a:rPr lang="en-US" dirty="0"/>
+              <a:t>Phase 6: more features like shield, sound, and keybindings.</a:t>
+            </a:r>
+            <a:endParaRPr lang="en-US" dirty="0"/>
+          </a:p>
+          <a:p>
+            <a:r>
+              <a:rPr lang="en-US" dirty="0"/>
+              <a:t>Some numbers: 85 commits, about 32 thousand lines of code, 68 Python files, 19 test suites, 4 Docker services, 8 characters, and 30 levels in 6 worlds.</a:t>
             </a:r>
             <a:endParaRPr lang="en-US" dirty="0"/>
           </a:p>
@@ -1392,8 +1714,50 @@
           <a:lstStyle/>
           <a:p>
             <a:r>
+              <a:rPr lang="en-US" b="1" dirty="0"/>
+              <a:t>SPEAKER NOTES  |  5:05 – 6:05  (60s)</a:t>
+            </a:r>
+            <a:endParaRPr lang="en-US" dirty="0"/>
+          </a:p>
+          <a:p>
+            <a:r>
               <a:rPr lang="en-US" dirty="0"/>
-              <a:t/>
+              <a:t>We had five big challenges.</a:t>
+            </a:r>
+            <a:endParaRPr lang="en-US" dirty="0"/>
+          </a:p>
+          <a:p>
+            <a:r>
+              <a:rPr lang="en-US" dirty="0"/>
+              <a:t>One: the game had to talk to the API with tokens. We made a special API client with retry and offline mode.</a:t>
+            </a:r>
+            <a:endParaRPr lang="en-US" dirty="0"/>
+          </a:p>
+          <a:p>
+            <a:r>
+              <a:rPr lang="en-US" dirty="0"/>
+              <a:t>Two: security. We protected against XSS, IDOR, and brute-force. We used a security facade, middleware, rate limiting, and data checking.</a:t>
+            </a:r>
+            <a:endParaRPr lang="en-US" dirty="0"/>
+          </a:p>
+          <a:p>
+            <a:r>
+              <a:rPr lang="en-US" dirty="0"/>
+              <a:t>Three: the game states. Menu, login, play, pause, game over, leaderboard. We wrote them clearly in the code.</a:t>
+            </a:r>
+            <a:endParaRPr lang="en-US" dirty="0"/>
+          </a:p>
+          <a:p>
+            <a:r>
+              <a:rPr lang="en-US" dirty="0"/>
+              <a:t>Four: the WebAssembly build with Pygbag. We used a special Dockerfile and a shared volume.</a:t>
+            </a:r>
+            <a:endParaRPr lang="en-US" dirty="0"/>
+          </a:p>
+          <a:p>
+            <a:r>
+              <a:rPr lang="en-US" dirty="0"/>
+              <a:t>Five: the tests. We wrote 19 test suites for auth, API, security, and more.</a:t>
             </a:r>
             <a:endParaRPr lang="en-US" dirty="0"/>
           </a:p>
@@ -1480,8 +1844,36 @@
           <a:lstStyle/>
           <a:p>
             <a:r>
+              <a:rPr lang="en-US" b="1" dirty="0"/>
+              <a:t>SPEAKER NOTES  |  6:05 – 6:45  (40s)</a:t>
+            </a:r>
+            <a:endParaRPr lang="en-US" dirty="0"/>
+          </a:p>
+          <a:p>
+            <a:r>
               <a:rPr lang="en-US" dirty="0"/>
-              <a:t/>
+              <a:t>What did we learn? Good things: the modular design let us work at the same time.</a:t>
+            </a:r>
+            <a:endParaRPr lang="en-US" dirty="0"/>
+          </a:p>
+          <a:p>
+            <a:r>
+              <a:rPr lang="en-US" dirty="0"/>
+              <a:t>Clean commits gave a clean history. Docker removed the 'it works on my computer' problem. Django Ninja gave free docs and checks.</a:t>
+            </a:r>
+            <a:endParaRPr lang="en-US" dirty="0"/>
+          </a:p>
+          <a:p>
+            <a:r>
+              <a:rPr lang="en-US" dirty="0"/>
+              <a:t>What we would change: use Docker from day one. Write more tests early. Maybe use React or Vue for the dashboard. And add multiplayer sooner.</a:t>
+            </a:r>
+            <a:endParaRPr lang="en-US" dirty="0"/>
+          </a:p>
+          <a:p>
+            <a:r>
+              <a:rPr lang="en-US" dirty="0"/>
+              <a:t>The best technical parts were the JWT system, the WASM build, and the security design.</a:t>
             </a:r>
             <a:endParaRPr lang="en-US" dirty="0"/>
           </a:p>
@@ -2071,6 +2463,45 @@
       </p:sp>
       <p:sp>
         <p:nvSpPr>
+          <p:cNvPr id="20" name="Cue Strip"/>
+          <p:cNvSpPr/>
+          <p:nvPr/>
+        </p:nvSpPr>
+        <p:spPr>
+          <a:xfrm>
+            <a:off x="731520" y="4443984"/>
+            <a:ext cx="7680960" cy="256032"/>
+          </a:xfrm>
+          <a:prstGeom prst="rect">
+            <a:avLst/>
+          </a:prstGeom>
+          <a:noFill/>
+          <a:ln/>
+        </p:spPr>
+        <p:txBody>
+          <a:bodyPr wrap="square" lIns="0" tIns="0" rIns="0" bIns="0" rtlCol="0" anchor="ctr"/>
+          <a:lstStyle/>
+          <a:p>
+            <a:pPr algn="l" indent="0" marL="0">
+              <a:buNone/>
+            </a:pPr>
+            <a:r>
+              <a:rPr lang="en-US" sz="1100" i="1" dirty="0">
+                <a:solidFill>
+                  <a:srgbClr val="533483"/>
+                </a:solidFill>
+                <a:latin typeface="Calibri" pitchFamily="34" charset="0"/>
+                <a:ea typeface="Calibri" pitchFamily="34" charset="-122"/>
+                <a:cs typeface="Calibri" pitchFamily="34" charset="-120"/>
+              </a:rPr>
+              <a:t>▸ Hugo → ARCAD3X = arcade + data tracking → Space Invaders 3 → 8-min full-stack demo</a:t>
+            </a:r>
+            <a:endParaRPr lang="en-US" sz="1100" i="1" dirty="0"/>
+          </a:p>
+        </p:txBody>
+      </p:sp>
+      <p:sp>
+        <p:nvSpPr>
           <p:cNvPr id="8" name="Shape 6"/>
           <p:cNvSpPr/>
           <p:nvPr/>
@@ -2390,7 +2821,7 @@
                 <a:ea typeface="Calibri" pitchFamily="34" charset="-122"/>
                 <a:cs typeface="Calibri" pitchFamily="34" charset="-120"/>
               </a:rPr>
-              <a:t>Auth, profiles, 8 characters, 25 levels</a:t>
+              <a:t>Auth, profiles, 8 characters, 30 levels</a:t>
             </a:r>
             <a:endParaRPr lang="en-US" sz="1300" dirty="0"/>
           </a:p>
@@ -2684,7 +3115,7 @@
                 <a:ea typeface="Calibri" pitchFamily="34" charset="-122"/>
                 <a:cs typeface="Calibri" pitchFamily="34" charset="-120"/>
               </a:rPr>
-              <a:t>Docker, WASM, 18 test suites, Swagger</a:t>
+              <a:t>Docker, WASM, 19 test suites, Swagger</a:t>
             </a:r>
             <a:endParaRPr lang="en-US" sz="1300" dirty="0"/>
           </a:p>
@@ -3319,7 +3750,7 @@
                 <a:ea typeface="Calibri" pitchFamily="34" charset="-122"/>
                 <a:cs typeface="Calibri" pitchFamily="34" charset="-120"/>
               </a:rPr>
-              <a:t>Level Selection → Grid by world (5 levels each)</a:t>
+              <a:t>Level Selection → Grid by world (5 levels each, 6 worlds)</a:t>
             </a:r>
             <a:endParaRPr lang="en-US" sz="1300" dirty="0"/>
           </a:p>
@@ -3639,7 +4070,7 @@
                 <a:ea typeface="Calibri" pitchFamily="34" charset="-122"/>
                 <a:cs typeface="Calibri" pitchFamily="34" charset="-120"/>
               </a:rPr>
-              <a:t>18 Test Suites</a:t>
+              <a:t>19 Test Suites</a:t>
             </a:r>
             <a:pPr algn="ctr" indent="0" marL="0">
               <a:buNone/>
@@ -3667,7 +4098,7 @@
                 <a:ea typeface="Calibri" pitchFamily="34" charset="-122"/>
                 <a:cs typeface="Calibri" pitchFamily="34" charset="-120"/>
               </a:rPr>
-              <a:t>5 Docker Services</a:t>
+              <a:t>4 Docker Services</a:t>
             </a:r>
             <a:pPr algn="ctr" indent="0" marL="0">
               <a:buNone/>
@@ -3765,6 +4196,45 @@
               <a:t>Hugo Ramos  •  Mélissa Sbibih  —  Holberton School France</a:t>
             </a:r>
             <a:endParaRPr lang="en-US" sz="1400" dirty="0"/>
+          </a:p>
+        </p:txBody>
+      </p:sp>
+      <p:sp>
+        <p:nvSpPr>
+          <p:cNvPr id="20" name="Cue Strip"/>
+          <p:cNvSpPr/>
+          <p:nvPr/>
+        </p:nvSpPr>
+        <p:spPr>
+          <a:xfrm>
+            <a:off x="731520" y="3155696"/>
+            <a:ext cx="7680960" cy="274320"/>
+          </a:xfrm>
+          <a:prstGeom prst="rect">
+            <a:avLst/>
+          </a:prstGeom>
+          <a:noFill/>
+          <a:ln/>
+        </p:spPr>
+        <p:txBody>
+          <a:bodyPr wrap="square" lIns="0" tIns="0" rIns="0" bIns="0" rtlCol="0" anchor="ctr"/>
+          <a:lstStyle/>
+          <a:p>
+            <a:pPr algn="ctr" indent="0" marL="0">
+              <a:buNone/>
+            </a:pPr>
+            <a:r>
+              <a:rPr lang="en-US" sz="1100" i="1" dirty="0">
+                <a:solidFill>
+                  <a:srgbClr val="533483"/>
+                </a:solidFill>
+                <a:latin typeface="Calibri" pitchFamily="34" charset="0"/>
+                <a:ea typeface="Calibri" pitchFamily="34" charset="-122"/>
+                <a:cs typeface="Calibri" pitchFamily="34" charset="-120"/>
+              </a:rPr>
+              <a:t>▸ recap badges → “code on GitHub — thank you” → invite questions</a:t>
+            </a:r>
+            <a:endParaRPr lang="en-US" sz="1100" i="1" dirty="0"/>
           </a:p>
         </p:txBody>
       </p:sp>
@@ -4348,8 +4818,12 @@
           <a:bodyPr wrap="square" lIns="0" tIns="0" rIns="0" bIns="0" rtlCol="0" anchor="t"/>
           <a:lstStyle/>
           <a:p>
-            <a:pPr indent="0" marL="0">
-              <a:buNone/>
+            <a:pPr marL="342900" indent="-342900">
+              <a:spcAft>
+                <a:spcPts val="400"/>
+              </a:spcAft>
+              <a:buSzPct val="100000"/>
+              <a:buChar char="•"/>
             </a:pPr>
             <a:r>
               <a:rPr lang="en-US" sz="1300" dirty="0">
@@ -4360,7 +4834,49 @@
                 <a:ea typeface="Calibri" pitchFamily="34" charset="-122"/>
                 <a:cs typeface="Calibri" pitchFamily="34" charset="-120"/>
               </a:rPr>
-              <a:t>A complete gaming ecosystem: 2D arcade game (Space Invaders style) + secure REST API with auth + web analytics dashboard — all orchestrated with Docker Compose.</a:t>
+              <a:t>2D arcade game (Space Invaders style)</a:t>
+            </a:r>
+            <a:endParaRPr lang="en-US" sz="1300" dirty="0"/>
+          </a:p>
+          <a:p>
+            <a:pPr marL="342900" indent="-342900">
+              <a:spcAft>
+                <a:spcPts val="400"/>
+              </a:spcAft>
+              <a:buSzPct val="100000"/>
+              <a:buChar char="•"/>
+            </a:pPr>
+            <a:r>
+              <a:rPr lang="en-US" sz="1300" dirty="0">
+                <a:solidFill>
+                  <a:srgbClr val="8B8BA3"/>
+                </a:solidFill>
+                <a:latin typeface="Calibri" pitchFamily="34" charset="0"/>
+                <a:ea typeface="Calibri" pitchFamily="34" charset="-122"/>
+                <a:cs typeface="Calibri" pitchFamily="34" charset="-120"/>
+              </a:rPr>
+              <a:t>Secure REST API with JWT auth</a:t>
+            </a:r>
+            <a:endParaRPr lang="en-US" sz="1300" dirty="0"/>
+          </a:p>
+          <a:p>
+            <a:pPr marL="342900" indent="-342900">
+              <a:spcAft>
+                <a:spcPts val="400"/>
+              </a:spcAft>
+              <a:buSzPct val="100000"/>
+              <a:buChar char="•"/>
+            </a:pPr>
+            <a:r>
+              <a:rPr lang="en-US" sz="1300" dirty="0">
+                <a:solidFill>
+                  <a:srgbClr val="8B8BA3"/>
+                </a:solidFill>
+                <a:latin typeface="Calibri" pitchFamily="34" charset="0"/>
+                <a:ea typeface="Calibri" pitchFamily="34" charset="-122"/>
+                <a:cs typeface="Calibri" pitchFamily="34" charset="-120"/>
+              </a:rPr>
+              <a:t>Web analytics dashboard — all via Docker Compose</a:t>
             </a:r>
             <a:endParaRPr lang="en-US" sz="1300" dirty="0"/>
           </a:p>
@@ -4584,8 +5100,12 @@
           <a:bodyPr wrap="square" lIns="0" tIns="0" rIns="0" bIns="0" rtlCol="0" anchor="t"/>
           <a:lstStyle/>
           <a:p>
-            <a:pPr indent="0" marL="0">
-              <a:buNone/>
+            <a:pPr marL="342900" indent="-342900">
+              <a:spcAft>
+                <a:spcPts val="400"/>
+              </a:spcAft>
+              <a:buSzPct val="100000"/>
+              <a:buChar char="•"/>
             </a:pPr>
             <a:r>
               <a:rPr lang="en-US" sz="1300" dirty="0">
@@ -4596,7 +5116,28 @@
                 <a:ea typeface="Calibri" pitchFamily="34" charset="-122"/>
                 <a:cs typeface="Calibri" pitchFamily="34" charset="-120"/>
               </a:rPr>
-              <a:t>Classic arcade games offer an ephemeral experience — no performance tracking, no history, no player comparison.</a:t>
+              <a:t>Arcade = fun, but ephemeral</a:t>
+            </a:r>
+            <a:endParaRPr lang="en-US" sz="1300" dirty="0"/>
+          </a:p>
+          <a:p>
+            <a:pPr marL="342900" indent="-342900">
+              <a:spcAft>
+                <a:spcPts val="400"/>
+              </a:spcAft>
+              <a:buSzPct val="100000"/>
+              <a:buChar char="•"/>
+            </a:pPr>
+            <a:r>
+              <a:rPr lang="en-US" sz="1300" dirty="0">
+                <a:solidFill>
+                  <a:srgbClr val="8B8BA3"/>
+                </a:solidFill>
+                <a:latin typeface="Calibri" pitchFamily="34" charset="0"/>
+                <a:ea typeface="Calibri" pitchFamily="34" charset="-122"/>
+                <a:cs typeface="Calibri" pitchFamily="34" charset="-120"/>
+              </a:rPr>
+              <a:t>No score history · no player comparison</a:t>
             </a:r>
             <a:endParaRPr lang="en-US" sz="1300" dirty="0"/>
           </a:p>
@@ -4709,8 +5250,12 @@
           <a:bodyPr wrap="square" lIns="0" tIns="0" rIns="0" bIns="0" rtlCol="0" anchor="t"/>
           <a:lstStyle/>
           <a:p>
-            <a:pPr indent="0" marL="0">
-              <a:buNone/>
+            <a:pPr marL="342900" indent="-342900">
+              <a:spcAft>
+                <a:spcPts val="400"/>
+              </a:spcAft>
+              <a:buSzPct val="100000"/>
+              <a:buChar char="•"/>
             </a:pPr>
             <a:r>
               <a:rPr lang="en-US" sz="1300" dirty="0">
@@ -4721,7 +5266,28 @@
                 <a:ea typeface="Calibri" pitchFamily="34" charset="-122"/>
                 <a:cs typeface="Calibri" pitchFamily="34" charset="-120"/>
               </a:rPr>
-              <a:t>Couple the excitement of arcade gaming with the introspection of analytics — track scores, compare players, visualize progress.</a:t>
+              <a:t>Arcade fun + analytics introspection</a:t>
+            </a:r>
+            <a:endParaRPr lang="en-US" sz="1300" dirty="0"/>
+          </a:p>
+          <a:p>
+            <a:pPr marL="342900" indent="-342900">
+              <a:spcAft>
+                <a:spcPts val="400"/>
+              </a:spcAft>
+              <a:buSzPct val="100000"/>
+              <a:buChar char="•"/>
+            </a:pPr>
+            <a:r>
+              <a:rPr lang="en-US" sz="1300" dirty="0">
+                <a:solidFill>
+                  <a:srgbClr val="8B8BA3"/>
+                </a:solidFill>
+                <a:latin typeface="Calibri" pitchFamily="34" charset="0"/>
+                <a:ea typeface="Calibri" pitchFamily="34" charset="-122"/>
+                <a:cs typeface="Calibri" pitchFamily="34" charset="-120"/>
+              </a:rPr>
+              <a:t>Track scores · compare players · visualize progress</a:t>
             </a:r>
             <a:endParaRPr lang="en-US" sz="1300" dirty="0"/>
           </a:p>
@@ -5941,7 +6507,7 @@
                 <a:ea typeface="Calibri" pitchFamily="34" charset="-122"/>
                 <a:cs typeface="Calibri" pitchFamily="34" charset="-120"/>
               </a:rPr>
-              <a:t>5 services, one command to launch</a:t>
+              <a:t>4 services, one command to launch</a:t>
             </a:r>
             <a:endParaRPr lang="en-US" sz="1300" dirty="0"/>
           </a:p>
@@ -7054,7 +7620,7 @@
                 <a:ea typeface="Arial Black" pitchFamily="34" charset="-122"/>
                 <a:cs typeface="Arial Black" pitchFamily="34" charset="-120"/>
               </a:rPr>
-              <a:t>Docker Architecture — 5 Services</a:t>
+              <a:t>Docker Architecture — 4 Services</a:t>
             </a:r>
             <a:endParaRPr lang="en-US" sz="2800" dirty="0"/>
           </a:p>
@@ -8439,7 +9005,7 @@
                 <a:ea typeface="Calibri" pitchFamily="34" charset="-122"/>
                 <a:cs typeface="Calibri" pitchFamily="34" charset="-120"/>
               </a:rPr>
-              <a:t>Docker Compose 5 services, Pygbag WASM, tests</a:t>
+              <a:t>Docker Compose 4 services, Pygbag WASM, tests</a:t>
             </a:r>
             <a:endParaRPr lang="en-US" sz="1200" dirty="0"/>
           </a:p>
@@ -8705,7 +9271,7 @@
                 <a:ea typeface="Calibri" pitchFamily="34" charset="-122"/>
                 <a:cs typeface="Calibri" pitchFamily="34" charset="-120"/>
               </a:rPr>
-              <a:t>67 commits</a:t>
+              <a:t>85 commits</a:t>
             </a:r>
             <a:endParaRPr lang="en-US" sz="1300" dirty="0"/>
           </a:p>
@@ -8726,7 +9292,7 @@
                 <a:ea typeface="Calibri" pitchFamily="34" charset="-122"/>
                 <a:cs typeface="Calibri" pitchFamily="34" charset="-120"/>
               </a:rPr>
-              <a:t>~220K lines of code</a:t>
+              <a:t>~32K lines of code</a:t>
             </a:r>
             <a:endParaRPr lang="en-US" sz="1300" dirty="0"/>
           </a:p>
@@ -8747,7 +9313,7 @@
                 <a:ea typeface="Calibri" pitchFamily="34" charset="-122"/>
                 <a:cs typeface="Calibri" pitchFamily="34" charset="-120"/>
               </a:rPr>
-              <a:t>646 Python files</a:t>
+              <a:t>68 Python files</a:t>
             </a:r>
             <a:endParaRPr lang="en-US" sz="1300" dirty="0"/>
           </a:p>
@@ -8768,7 +9334,7 @@
                 <a:ea typeface="Calibri" pitchFamily="34" charset="-122"/>
                 <a:cs typeface="Calibri" pitchFamily="34" charset="-120"/>
               </a:rPr>
-              <a:t>18 test suites</a:t>
+              <a:t>19 test suites</a:t>
             </a:r>
             <a:endParaRPr lang="en-US" sz="1300" dirty="0"/>
           </a:p>
@@ -8789,7 +9355,7 @@
                 <a:ea typeface="Calibri" pitchFamily="34" charset="-122"/>
                 <a:cs typeface="Calibri" pitchFamily="34" charset="-120"/>
               </a:rPr>
-              <a:t>5 Docker services</a:t>
+              <a:t>4 Docker services</a:t>
             </a:r>
             <a:endParaRPr lang="en-US" sz="1300" dirty="0"/>
           </a:p>
@@ -8831,7 +9397,7 @@
                 <a:ea typeface="Calibri" pitchFamily="34" charset="-122"/>
                 <a:cs typeface="Calibri" pitchFamily="34" charset="-120"/>
               </a:rPr>
-              <a:t>25 levels (5 worlds)</a:t>
+              <a:t>30 levels (6 worlds)</a:t>
             </a:r>
             <a:endParaRPr lang="en-US" sz="1300" dirty="0"/>
           </a:p>
@@ -9055,8 +9621,12 @@
           <a:bodyPr wrap="square" lIns="0" tIns="0" rIns="0" bIns="0" rtlCol="0" anchor="t"/>
           <a:lstStyle/>
           <a:p>
-            <a:pPr indent="0" marL="0">
-              <a:buNone/>
+            <a:pPr marL="342900" indent="-342900">
+              <a:spcAft>
+                <a:spcPts val="400"/>
+              </a:spcAft>
+              <a:buSzPct val="100000"/>
+              <a:buChar char="•"/>
             </a:pPr>
             <a:r>
               <a:rPr lang="en-US" sz="1300" dirty="0">
@@ -9067,7 +9637,28 @@
                 <a:ea typeface="Calibri" pitchFamily="34" charset="-122"/>
                 <a:cs typeface="Calibri" pitchFamily="34" charset="-120"/>
               </a:rPr>
-              <a:t>Pygame client ↔ REST API via HTTP + JWT. Solution: dedicated api_client.py with token management, retry, offline fallback.</a:t>
+              <a:t>Pygame ↔ REST API over HTTP + JWT</a:t>
+            </a:r>
+            <a:endParaRPr lang="en-US" sz="1300" dirty="0"/>
+          </a:p>
+          <a:p>
+            <a:pPr marL="342900" indent="-342900">
+              <a:spcAft>
+                <a:spcPts val="400"/>
+              </a:spcAft>
+              <a:buSzPct val="100000"/>
+              <a:buChar char="•"/>
+            </a:pPr>
+            <a:r>
+              <a:rPr lang="en-US" sz="1300" dirty="0">
+                <a:solidFill>
+                  <a:srgbClr val="8B8BA3"/>
+                </a:solidFill>
+                <a:latin typeface="Calibri" pitchFamily="34" charset="0"/>
+                <a:ea typeface="Calibri" pitchFamily="34" charset="-122"/>
+                <a:cs typeface="Calibri" pitchFamily="34" charset="-120"/>
+              </a:rPr>
+              <a:t>Fix: api_client.py — tokens, retry, offline</a:t>
             </a:r>
             <a:endParaRPr lang="en-US" sz="1300" dirty="0"/>
           </a:p>
@@ -9180,8 +9771,12 @@
           <a:bodyPr wrap="square" lIns="0" tIns="0" rIns="0" bIns="0" rtlCol="0" anchor="t"/>
           <a:lstStyle/>
           <a:p>
-            <a:pPr indent="0" marL="0">
-              <a:buNone/>
+            <a:pPr marL="342900" indent="-342900">
+              <a:spcAft>
+                <a:spcPts val="400"/>
+              </a:spcAft>
+              <a:buSzPct val="100000"/>
+              <a:buChar char="•"/>
             </a:pPr>
             <a:r>
               <a:rPr lang="en-US" sz="1300" dirty="0">
@@ -9192,7 +9787,28 @@
                 <a:ea typeface="Calibri" pitchFamily="34" charset="-122"/>
                 <a:cs typeface="Calibri" pitchFamily="34" charset="-120"/>
               </a:rPr>
-              <a:t>Solution: Security Facade (2 layers) + Django middleware + Redis rate limiting + Pydantic validation.</a:t>
+              <a:t>Threats: XSS · IDOR · brute-force</a:t>
+            </a:r>
+            <a:endParaRPr lang="en-US" sz="1300" dirty="0"/>
+          </a:p>
+          <a:p>
+            <a:pPr marL="342900" indent="-342900">
+              <a:spcAft>
+                <a:spcPts val="400"/>
+              </a:spcAft>
+              <a:buSzPct val="100000"/>
+              <a:buChar char="•"/>
+            </a:pPr>
+            <a:r>
+              <a:rPr lang="en-US" sz="1300" dirty="0">
+                <a:solidFill>
+                  <a:srgbClr val="8B8BA3"/>
+                </a:solidFill>
+                <a:latin typeface="Calibri" pitchFamily="34" charset="0"/>
+                <a:ea typeface="Calibri" pitchFamily="34" charset="-122"/>
+                <a:cs typeface="Calibri" pitchFamily="34" charset="-120"/>
+              </a:rPr>
+              <a:t>Fix: Facade (2 layers) + middleware + Redis limit + Pydantic</a:t>
             </a:r>
             <a:endParaRPr lang="en-US" sz="1300" dirty="0"/>
           </a:p>
@@ -9305,8 +9921,12 @@
           <a:bodyPr wrap="square" lIns="0" tIns="0" rIns="0" bIns="0" rtlCol="0" anchor="t"/>
           <a:lstStyle/>
           <a:p>
-            <a:pPr indent="0" marL="0">
-              <a:buNone/>
+            <a:pPr marL="342900" indent="-342900">
+              <a:spcAft>
+                <a:spcPts val="400"/>
+              </a:spcAft>
+              <a:buSzPct val="100000"/>
+              <a:buChar char="•"/>
             </a:pPr>
             <a:r>
               <a:rPr lang="en-US" sz="1300" dirty="0">
@@ -9317,7 +9937,28 @@
                 <a:ea typeface="Calibri" pitchFamily="34" charset="-122"/>
                 <a:cs typeface="Calibri" pitchFamily="34" charset="-120"/>
               </a:rPr>
-              <a:t>Complex transitions: Menu → Auth → Select → Play → Pause → Game Over → Leaderboard. Solution: explicit states in game.py.</a:t>
+              <a:t>7 states: Menu→Auth→Select→Play→Pause→Over→Board</a:t>
+            </a:r>
+            <a:endParaRPr lang="en-US" sz="1300" dirty="0"/>
+          </a:p>
+          <a:p>
+            <a:pPr marL="342900" indent="-342900">
+              <a:spcAft>
+                <a:spcPts val="400"/>
+              </a:spcAft>
+              <a:buSzPct val="100000"/>
+              <a:buChar char="•"/>
+            </a:pPr>
+            <a:r>
+              <a:rPr lang="en-US" sz="1300" dirty="0">
+                <a:solidFill>
+                  <a:srgbClr val="8B8BA3"/>
+                </a:solidFill>
+                <a:latin typeface="Calibri" pitchFamily="34" charset="0"/>
+                <a:ea typeface="Calibri" pitchFamily="34" charset="-122"/>
+                <a:cs typeface="Calibri" pitchFamily="34" charset="-120"/>
+              </a:rPr>
+              <a:t>Fix: explicit state machine in game.py</a:t>
             </a:r>
             <a:endParaRPr lang="en-US" sz="1300" dirty="0"/>
           </a:p>
@@ -9430,8 +10071,12 @@
           <a:bodyPr wrap="square" lIns="0" tIns="0" rIns="0" bIns="0" rtlCol="0" anchor="t"/>
           <a:lstStyle/>
           <a:p>
-            <a:pPr indent="0" marL="0">
-              <a:buNone/>
+            <a:pPr marL="342900" indent="-342900">
+              <a:spcAft>
+                <a:spcPts val="400"/>
+              </a:spcAft>
+              <a:buSzPct val="100000"/>
+              <a:buChar char="•"/>
             </a:pPr>
             <a:r>
               <a:rPr lang="en-US" sz="1300" dirty="0">
@@ -9442,7 +10087,28 @@
                 <a:ea typeface="Calibri" pitchFamily="34" charset="-122"/>
                 <a:cs typeface="Calibri" pitchFamily="34" charset="-120"/>
               </a:rPr>
-              <a:t>Compile Pygame to WASM via Pygbag. Solution: dedicated Dockerfile + shared volume with Nginx.</a:t>
+              <a:t>Compile Pygame → WASM via Pygbag</a:t>
+            </a:r>
+            <a:endParaRPr lang="en-US" sz="1300" dirty="0"/>
+          </a:p>
+          <a:p>
+            <a:pPr marL="342900" indent="-342900">
+              <a:spcAft>
+                <a:spcPts val="400"/>
+              </a:spcAft>
+              <a:buSzPct val="100000"/>
+              <a:buChar char="•"/>
+            </a:pPr>
+            <a:r>
+              <a:rPr lang="en-US" sz="1300" dirty="0">
+                <a:solidFill>
+                  <a:srgbClr val="8B8BA3"/>
+                </a:solidFill>
+                <a:latin typeface="Calibri" pitchFamily="34" charset="0"/>
+                <a:ea typeface="Calibri" pitchFamily="34" charset="-122"/>
+                <a:cs typeface="Calibri" pitchFamily="34" charset="-120"/>
+              </a:rPr>
+              <a:t>Fix: dedicated Dockerfile + shared volume w/ Nginx</a:t>
             </a:r>
             <a:endParaRPr lang="en-US" sz="1300" dirty="0"/>
           </a:p>
@@ -9555,8 +10221,12 @@
           <a:bodyPr wrap="square" lIns="0" tIns="0" rIns="0" bIns="0" rtlCol="0" anchor="t"/>
           <a:lstStyle/>
           <a:p>
-            <a:pPr indent="0" marL="0">
-              <a:buNone/>
+            <a:pPr marL="342900" indent="-342900">
+              <a:spcAft>
+                <a:spcPts val="400"/>
+              </a:spcAft>
+              <a:buSzPct val="100000"/>
+              <a:buChar char="•"/>
             </a:pPr>
             <a:r>
               <a:rPr lang="en-US" sz="1300" dirty="0">
@@ -9567,7 +10237,28 @@
                 <a:ea typeface="Calibri" pitchFamily="34" charset="-122"/>
                 <a:cs typeface="Calibri" pitchFamily="34" charset="-120"/>
               </a:rPr>
-              <a:t>Solution: 18 test suites — auth, API, security, E2E, performance, edge cases.</a:t>
+              <a:t>19 test suites</a:t>
+            </a:r>
+            <a:endParaRPr lang="en-US" sz="1300" dirty="0"/>
+          </a:p>
+          <a:p>
+            <a:pPr marL="342900" indent="-342900">
+              <a:spcAft>
+                <a:spcPts val="400"/>
+              </a:spcAft>
+              <a:buSzPct val="100000"/>
+              <a:buChar char="•"/>
+            </a:pPr>
+            <a:r>
+              <a:rPr lang="en-US" sz="1300" dirty="0">
+                <a:solidFill>
+                  <a:srgbClr val="8B8BA3"/>
+                </a:solidFill>
+                <a:latin typeface="Calibri" pitchFamily="34" charset="0"/>
+                <a:ea typeface="Calibri" pitchFamily="34" charset="-122"/>
+                <a:cs typeface="Calibri" pitchFamily="34" charset="-120"/>
+              </a:rPr>
+              <a:t>auth · API · security · E2E · perf · edge cases</a:t>
             </a:r>
             <a:endParaRPr lang="en-US" sz="1300" dirty="0"/>
           </a:p>

</xml_diff>